<commit_message>
v4: replace word freq with exam format
</commit_message>
<xml_diff>
--- a/Introduction_to_Reading_Assessment.pptx
+++ b/Introduction_to_Reading_Assessment.pptx
@@ -4687,7 +4687,7 @@
                   <a:srgbClr val="000000"/>
                 </a:solidFill>
               </a:rPr>
-              <a:t>Common Language in Abstracts</a:t>
+              <a:t>Reading Assessment: 6 Questions</a:t>
             </a:r>
           </a:p>
         </p:txBody>
@@ -4700,10 +4700,914 @@
         </p:nvSpPr>
         <p:spPr>
           <a:xfrm>
-            <a:off x="998220" y="1463040"/>
-            <a:ext cx="2377440" cy="2194560"/>
+            <a:off x="914400" y="1463040"/>
+            <a:ext cx="4846320" cy="914400"/>
           </a:xfrm>
           <a:prstGeom prst="roundRect">
+            <a:avLst/>
+          </a:prstGeom>
+          <a:solidFill>
+            <a:srgbClr val="F5F0FA"/>
+          </a:solidFill>
+          <a:ln>
+            <a:noFill/>
+          </a:ln>
+        </p:spPr>
+        <p:style>
+          <a:lnRef idx="1">
+            <a:schemeClr val="accent1"/>
+          </a:lnRef>
+          <a:fillRef idx="3">
+            <a:schemeClr val="accent1"/>
+          </a:fillRef>
+          <a:effectRef idx="2">
+            <a:schemeClr val="accent1"/>
+          </a:effectRef>
+          <a:fontRef idx="minor">
+            <a:schemeClr val="lt1"/>
+          </a:fontRef>
+        </p:style>
+        <p:txBody>
+          <a:bodyPr rtlCol="0" anchor="ctr"/>
+          <a:lstStyle/>
+          <a:p>
+            <a:pPr algn="ctr"/>
+          </a:p>
+        </p:txBody>
+      </p:sp>
+      <p:sp>
+        <p:nvSpPr>
+          <p:cNvPr id="5" name="TextBox 4"/>
+          <p:cNvSpPr txBox="1"/>
+          <p:nvPr/>
+        </p:nvSpPr>
+        <p:spPr>
+          <a:xfrm>
+            <a:off x="1097280" y="1554480"/>
+            <a:ext cx="822960" cy="731520"/>
+          </a:xfrm>
+          <a:prstGeom prst="rect">
+            <a:avLst/>
+          </a:prstGeom>
+          <a:noFill/>
+        </p:spPr>
+        <p:txBody>
+          <a:bodyPr wrap="square">
+            <a:spAutoFit/>
+          </a:bodyPr>
+          <a:lstStyle/>
+          <a:p>
+            <a:pPr algn="ctr"/>
+            <a:r>
+              <a:rPr b="1" sz="2400">
+                <a:solidFill>
+                  <a:srgbClr val="7C3A9E"/>
+                </a:solidFill>
+              </a:rPr>
+              <a:t>Q1</a:t>
+            </a:r>
+          </a:p>
+        </p:txBody>
+      </p:sp>
+      <p:sp>
+        <p:nvSpPr>
+          <p:cNvPr id="6" name="TextBox 5"/>
+          <p:cNvSpPr txBox="1"/>
+          <p:nvPr/>
+        </p:nvSpPr>
+        <p:spPr>
+          <a:xfrm>
+            <a:off x="2011680" y="1554480"/>
+            <a:ext cx="3566160" cy="457200"/>
+          </a:xfrm>
+          <a:prstGeom prst="rect">
+            <a:avLst/>
+          </a:prstGeom>
+          <a:noFill/>
+        </p:spPr>
+        <p:txBody>
+          <a:bodyPr wrap="square">
+            <a:spAutoFit/>
+          </a:bodyPr>
+          <a:lstStyle/>
+          <a:p>
+            <a:pPr algn="l"/>
+            <a:r>
+              <a:rPr b="1" sz="1800">
+                <a:solidFill>
+                  <a:srgbClr val="000000"/>
+                </a:solidFill>
+              </a:rPr>
+              <a:t>Significance</a:t>
+            </a:r>
+          </a:p>
+        </p:txBody>
+      </p:sp>
+      <p:sp>
+        <p:nvSpPr>
+          <p:cNvPr id="7" name="TextBox 6"/>
+          <p:cNvSpPr txBox="1"/>
+          <p:nvPr/>
+        </p:nvSpPr>
+        <p:spPr>
+          <a:xfrm>
+            <a:off x="2011680" y="1993392"/>
+            <a:ext cx="3566160" cy="365760"/>
+          </a:xfrm>
+          <a:prstGeom prst="rect">
+            <a:avLst/>
+          </a:prstGeom>
+          <a:noFill/>
+        </p:spPr>
+        <p:txBody>
+          <a:bodyPr wrap="square">
+            <a:spAutoFit/>
+          </a:bodyPr>
+          <a:lstStyle/>
+          <a:p>
+            <a:pPr algn="l"/>
+            <a:r>
+              <a:rPr b="1" sz="1400">
+                <a:solidFill>
+                  <a:srgbClr val="666666"/>
+                </a:solidFill>
+              </a:rPr>
+              <a:t>研究意义是什么？</a:t>
+            </a:r>
+          </a:p>
+        </p:txBody>
+      </p:sp>
+      <p:sp>
+        <p:nvSpPr>
+          <p:cNvPr id="8" name="Rounded Rectangle 7"/>
+          <p:cNvSpPr/>
+          <p:nvPr/>
+        </p:nvSpPr>
+        <p:spPr>
+          <a:xfrm>
+            <a:off x="914400" y="2560320"/>
+            <a:ext cx="4846320" cy="914400"/>
+          </a:xfrm>
+          <a:prstGeom prst="roundRect">
+            <a:avLst/>
+          </a:prstGeom>
+          <a:solidFill>
+            <a:srgbClr val="F5F0FA"/>
+          </a:solidFill>
+          <a:ln>
+            <a:noFill/>
+          </a:ln>
+        </p:spPr>
+        <p:style>
+          <a:lnRef idx="1">
+            <a:schemeClr val="accent1"/>
+          </a:lnRef>
+          <a:fillRef idx="3">
+            <a:schemeClr val="accent1"/>
+          </a:fillRef>
+          <a:effectRef idx="2">
+            <a:schemeClr val="accent1"/>
+          </a:effectRef>
+          <a:fontRef idx="minor">
+            <a:schemeClr val="lt1"/>
+          </a:fontRef>
+        </p:style>
+        <p:txBody>
+          <a:bodyPr rtlCol="0" anchor="ctr"/>
+          <a:lstStyle/>
+          <a:p>
+            <a:pPr algn="ctr"/>
+          </a:p>
+        </p:txBody>
+      </p:sp>
+      <p:sp>
+        <p:nvSpPr>
+          <p:cNvPr id="9" name="TextBox 8"/>
+          <p:cNvSpPr txBox="1"/>
+          <p:nvPr/>
+        </p:nvSpPr>
+        <p:spPr>
+          <a:xfrm>
+            <a:off x="1097280" y="2651760"/>
+            <a:ext cx="822960" cy="731520"/>
+          </a:xfrm>
+          <a:prstGeom prst="rect">
+            <a:avLst/>
+          </a:prstGeom>
+          <a:noFill/>
+        </p:spPr>
+        <p:txBody>
+          <a:bodyPr wrap="square">
+            <a:spAutoFit/>
+          </a:bodyPr>
+          <a:lstStyle/>
+          <a:p>
+            <a:pPr algn="ctr"/>
+            <a:r>
+              <a:rPr b="1" sz="2400">
+                <a:solidFill>
+                  <a:srgbClr val="502379"/>
+                </a:solidFill>
+              </a:rPr>
+              <a:t>Q2</a:t>
+            </a:r>
+          </a:p>
+        </p:txBody>
+      </p:sp>
+      <p:sp>
+        <p:nvSpPr>
+          <p:cNvPr id="10" name="TextBox 9"/>
+          <p:cNvSpPr txBox="1"/>
+          <p:nvPr/>
+        </p:nvSpPr>
+        <p:spPr>
+          <a:xfrm>
+            <a:off x="2011680" y="2651760"/>
+            <a:ext cx="3566160" cy="457200"/>
+          </a:xfrm>
+          <a:prstGeom prst="rect">
+            <a:avLst/>
+          </a:prstGeom>
+          <a:noFill/>
+        </p:spPr>
+        <p:txBody>
+          <a:bodyPr wrap="square">
+            <a:spAutoFit/>
+          </a:bodyPr>
+          <a:lstStyle/>
+          <a:p>
+            <a:pPr algn="l"/>
+            <a:r>
+              <a:rPr b="1" sz="1800">
+                <a:solidFill>
+                  <a:srgbClr val="000000"/>
+                </a:solidFill>
+              </a:rPr>
+              <a:t>Main Aim</a:t>
+            </a:r>
+          </a:p>
+        </p:txBody>
+      </p:sp>
+      <p:sp>
+        <p:nvSpPr>
+          <p:cNvPr id="11" name="TextBox 10"/>
+          <p:cNvSpPr txBox="1"/>
+          <p:nvPr/>
+        </p:nvSpPr>
+        <p:spPr>
+          <a:xfrm>
+            <a:off x="2011680" y="3090672"/>
+            <a:ext cx="3566160" cy="365760"/>
+          </a:xfrm>
+          <a:prstGeom prst="rect">
+            <a:avLst/>
+          </a:prstGeom>
+          <a:noFill/>
+        </p:spPr>
+        <p:txBody>
+          <a:bodyPr wrap="square">
+            <a:spAutoFit/>
+          </a:bodyPr>
+          <a:lstStyle/>
+          <a:p>
+            <a:pPr algn="l"/>
+            <a:r>
+              <a:rPr b="1" sz="1400">
+                <a:solidFill>
+                  <a:srgbClr val="666666"/>
+                </a:solidFill>
+              </a:rPr>
+              <a:t>研究目的是什么？</a:t>
+            </a:r>
+          </a:p>
+        </p:txBody>
+      </p:sp>
+      <p:sp>
+        <p:nvSpPr>
+          <p:cNvPr id="12" name="Rounded Rectangle 11"/>
+          <p:cNvSpPr/>
+          <p:nvPr/>
+        </p:nvSpPr>
+        <p:spPr>
+          <a:xfrm>
+            <a:off x="914400" y="3657600"/>
+            <a:ext cx="4846320" cy="914400"/>
+          </a:xfrm>
+          <a:prstGeom prst="roundRect">
+            <a:avLst/>
+          </a:prstGeom>
+          <a:solidFill>
+            <a:srgbClr val="F5F0FA"/>
+          </a:solidFill>
+          <a:ln>
+            <a:noFill/>
+          </a:ln>
+        </p:spPr>
+        <p:style>
+          <a:lnRef idx="1">
+            <a:schemeClr val="accent1"/>
+          </a:lnRef>
+          <a:fillRef idx="3">
+            <a:schemeClr val="accent1"/>
+          </a:fillRef>
+          <a:effectRef idx="2">
+            <a:schemeClr val="accent1"/>
+          </a:effectRef>
+          <a:fontRef idx="minor">
+            <a:schemeClr val="lt1"/>
+          </a:fontRef>
+        </p:style>
+        <p:txBody>
+          <a:bodyPr rtlCol="0" anchor="ctr"/>
+          <a:lstStyle/>
+          <a:p>
+            <a:pPr algn="ctr"/>
+          </a:p>
+        </p:txBody>
+      </p:sp>
+      <p:sp>
+        <p:nvSpPr>
+          <p:cNvPr id="13" name="TextBox 12"/>
+          <p:cNvSpPr txBox="1"/>
+          <p:nvPr/>
+        </p:nvSpPr>
+        <p:spPr>
+          <a:xfrm>
+            <a:off x="1097280" y="3749040"/>
+            <a:ext cx="822960" cy="731520"/>
+          </a:xfrm>
+          <a:prstGeom prst="rect">
+            <a:avLst/>
+          </a:prstGeom>
+          <a:noFill/>
+        </p:spPr>
+        <p:txBody>
+          <a:bodyPr wrap="square">
+            <a:spAutoFit/>
+          </a:bodyPr>
+          <a:lstStyle/>
+          <a:p>
+            <a:pPr algn="ctr"/>
+            <a:r>
+              <a:rPr b="1" sz="2400">
+                <a:solidFill>
+                  <a:srgbClr val="7C3A9E"/>
+                </a:solidFill>
+              </a:rPr>
+              <a:t>Q3</a:t>
+            </a:r>
+          </a:p>
+        </p:txBody>
+      </p:sp>
+      <p:sp>
+        <p:nvSpPr>
+          <p:cNvPr id="14" name="TextBox 13"/>
+          <p:cNvSpPr txBox="1"/>
+          <p:nvPr/>
+        </p:nvSpPr>
+        <p:spPr>
+          <a:xfrm>
+            <a:off x="2011680" y="3749040"/>
+            <a:ext cx="3566160" cy="457200"/>
+          </a:xfrm>
+          <a:prstGeom prst="rect">
+            <a:avLst/>
+          </a:prstGeom>
+          <a:noFill/>
+        </p:spPr>
+        <p:txBody>
+          <a:bodyPr wrap="square">
+            <a:spAutoFit/>
+          </a:bodyPr>
+          <a:lstStyle/>
+          <a:p>
+            <a:pPr algn="l"/>
+            <a:r>
+              <a:rPr b="1" sz="1800">
+                <a:solidFill>
+                  <a:srgbClr val="000000"/>
+                </a:solidFill>
+              </a:rPr>
+              <a:t>Method</a:t>
+            </a:r>
+          </a:p>
+        </p:txBody>
+      </p:sp>
+      <p:sp>
+        <p:nvSpPr>
+          <p:cNvPr id="15" name="TextBox 14"/>
+          <p:cNvSpPr txBox="1"/>
+          <p:nvPr/>
+        </p:nvSpPr>
+        <p:spPr>
+          <a:xfrm>
+            <a:off x="2011680" y="4187952"/>
+            <a:ext cx="3566160" cy="365760"/>
+          </a:xfrm>
+          <a:prstGeom prst="rect">
+            <a:avLst/>
+          </a:prstGeom>
+          <a:noFill/>
+        </p:spPr>
+        <p:txBody>
+          <a:bodyPr wrap="square">
+            <a:spAutoFit/>
+          </a:bodyPr>
+          <a:lstStyle/>
+          <a:p>
+            <a:pPr algn="l"/>
+            <a:r>
+              <a:rPr b="1" sz="1400">
+                <a:solidFill>
+                  <a:srgbClr val="666666"/>
+                </a:solidFill>
+              </a:rPr>
+              <a:t>研究怎么做的？</a:t>
+            </a:r>
+          </a:p>
+        </p:txBody>
+      </p:sp>
+      <p:sp>
+        <p:nvSpPr>
+          <p:cNvPr id="16" name="Rounded Rectangle 15"/>
+          <p:cNvSpPr/>
+          <p:nvPr/>
+        </p:nvSpPr>
+        <p:spPr>
+          <a:xfrm>
+            <a:off x="914400" y="4754880"/>
+            <a:ext cx="4846320" cy="914400"/>
+          </a:xfrm>
+          <a:prstGeom prst="roundRect">
+            <a:avLst/>
+          </a:prstGeom>
+          <a:solidFill>
+            <a:srgbClr val="F5F0FA"/>
+          </a:solidFill>
+          <a:ln>
+            <a:noFill/>
+          </a:ln>
+        </p:spPr>
+        <p:style>
+          <a:lnRef idx="1">
+            <a:schemeClr val="accent1"/>
+          </a:lnRef>
+          <a:fillRef idx="3">
+            <a:schemeClr val="accent1"/>
+          </a:fillRef>
+          <a:effectRef idx="2">
+            <a:schemeClr val="accent1"/>
+          </a:effectRef>
+          <a:fontRef idx="minor">
+            <a:schemeClr val="lt1"/>
+          </a:fontRef>
+        </p:style>
+        <p:txBody>
+          <a:bodyPr rtlCol="0" anchor="ctr"/>
+          <a:lstStyle/>
+          <a:p>
+            <a:pPr algn="ctr"/>
+          </a:p>
+        </p:txBody>
+      </p:sp>
+      <p:sp>
+        <p:nvSpPr>
+          <p:cNvPr id="17" name="TextBox 16"/>
+          <p:cNvSpPr txBox="1"/>
+          <p:nvPr/>
+        </p:nvSpPr>
+        <p:spPr>
+          <a:xfrm>
+            <a:off x="1097280" y="4846320"/>
+            <a:ext cx="822960" cy="731520"/>
+          </a:xfrm>
+          <a:prstGeom prst="rect">
+            <a:avLst/>
+          </a:prstGeom>
+          <a:noFill/>
+        </p:spPr>
+        <p:txBody>
+          <a:bodyPr wrap="square">
+            <a:spAutoFit/>
+          </a:bodyPr>
+          <a:lstStyle/>
+          <a:p>
+            <a:pPr algn="ctr"/>
+            <a:r>
+              <a:rPr b="1" sz="2400">
+                <a:solidFill>
+                  <a:srgbClr val="502379"/>
+                </a:solidFill>
+              </a:rPr>
+              <a:t>Q4</a:t>
+            </a:r>
+          </a:p>
+        </p:txBody>
+      </p:sp>
+      <p:sp>
+        <p:nvSpPr>
+          <p:cNvPr id="18" name="TextBox 17"/>
+          <p:cNvSpPr txBox="1"/>
+          <p:nvPr/>
+        </p:nvSpPr>
+        <p:spPr>
+          <a:xfrm>
+            <a:off x="2011680" y="4846320"/>
+            <a:ext cx="3566160" cy="457200"/>
+          </a:xfrm>
+          <a:prstGeom prst="rect">
+            <a:avLst/>
+          </a:prstGeom>
+          <a:noFill/>
+        </p:spPr>
+        <p:txBody>
+          <a:bodyPr wrap="square">
+            <a:spAutoFit/>
+          </a:bodyPr>
+          <a:lstStyle/>
+          <a:p>
+            <a:pPr algn="l"/>
+            <a:r>
+              <a:rPr b="1" sz="1800">
+                <a:solidFill>
+                  <a:srgbClr val="000000"/>
+                </a:solidFill>
+              </a:rPr>
+              <a:t>Findings</a:t>
+            </a:r>
+          </a:p>
+        </p:txBody>
+      </p:sp>
+      <p:sp>
+        <p:nvSpPr>
+          <p:cNvPr id="19" name="TextBox 18"/>
+          <p:cNvSpPr txBox="1"/>
+          <p:nvPr/>
+        </p:nvSpPr>
+        <p:spPr>
+          <a:xfrm>
+            <a:off x="2011680" y="5285232"/>
+            <a:ext cx="3566160" cy="365760"/>
+          </a:xfrm>
+          <a:prstGeom prst="rect">
+            <a:avLst/>
+          </a:prstGeom>
+          <a:noFill/>
+        </p:spPr>
+        <p:txBody>
+          <a:bodyPr wrap="square">
+            <a:spAutoFit/>
+          </a:bodyPr>
+          <a:lstStyle/>
+          <a:p>
+            <a:pPr algn="l"/>
+            <a:r>
+              <a:rPr b="1" sz="1400">
+                <a:solidFill>
+                  <a:srgbClr val="666666"/>
+                </a:solidFill>
+              </a:rPr>
+              <a:t>发现了什么？</a:t>
+            </a:r>
+          </a:p>
+        </p:txBody>
+      </p:sp>
+      <p:sp>
+        <p:nvSpPr>
+          <p:cNvPr id="20" name="Rounded Rectangle 19"/>
+          <p:cNvSpPr/>
+          <p:nvPr/>
+        </p:nvSpPr>
+        <p:spPr>
+          <a:xfrm>
+            <a:off x="6217920" y="1463040"/>
+            <a:ext cx="4846320" cy="1383533"/>
+          </a:xfrm>
+          <a:prstGeom prst="roundRect">
+            <a:avLst/>
+          </a:prstGeom>
+          <a:solidFill>
+            <a:srgbClr val="F5F0FA"/>
+          </a:solidFill>
+          <a:ln>
+            <a:noFill/>
+          </a:ln>
+        </p:spPr>
+        <p:style>
+          <a:lnRef idx="1">
+            <a:schemeClr val="accent1"/>
+          </a:lnRef>
+          <a:fillRef idx="3">
+            <a:schemeClr val="accent1"/>
+          </a:fillRef>
+          <a:effectRef idx="2">
+            <a:schemeClr val="accent1"/>
+          </a:effectRef>
+          <a:fontRef idx="minor">
+            <a:schemeClr val="lt1"/>
+          </a:fontRef>
+        </p:style>
+        <p:txBody>
+          <a:bodyPr rtlCol="0" anchor="ctr"/>
+          <a:lstStyle/>
+          <a:p>
+            <a:pPr algn="ctr"/>
+          </a:p>
+        </p:txBody>
+      </p:sp>
+      <p:sp>
+        <p:nvSpPr>
+          <p:cNvPr id="21" name="TextBox 20"/>
+          <p:cNvSpPr txBox="1"/>
+          <p:nvPr/>
+        </p:nvSpPr>
+        <p:spPr>
+          <a:xfrm>
+            <a:off x="6400800" y="1645920"/>
+            <a:ext cx="822960" cy="731520"/>
+          </a:xfrm>
+          <a:prstGeom prst="rect">
+            <a:avLst/>
+          </a:prstGeom>
+          <a:noFill/>
+        </p:spPr>
+        <p:txBody>
+          <a:bodyPr wrap="square">
+            <a:spAutoFit/>
+          </a:bodyPr>
+          <a:lstStyle/>
+          <a:p>
+            <a:pPr algn="ctr"/>
+            <a:r>
+              <a:rPr b="1" sz="2400">
+                <a:solidFill>
+                  <a:srgbClr val="E86A17"/>
+                </a:solidFill>
+              </a:rPr>
+              <a:t>Q5</a:t>
+            </a:r>
+          </a:p>
+        </p:txBody>
+      </p:sp>
+      <p:sp>
+        <p:nvSpPr>
+          <p:cNvPr id="22" name="TextBox 21"/>
+          <p:cNvSpPr txBox="1"/>
+          <p:nvPr/>
+        </p:nvSpPr>
+        <p:spPr>
+          <a:xfrm>
+            <a:off x="7315200" y="1645920"/>
+            <a:ext cx="3566160" cy="457200"/>
+          </a:xfrm>
+          <a:prstGeom prst="rect">
+            <a:avLst/>
+          </a:prstGeom>
+          <a:noFill/>
+        </p:spPr>
+        <p:txBody>
+          <a:bodyPr wrap="square">
+            <a:spAutoFit/>
+          </a:bodyPr>
+          <a:lstStyle/>
+          <a:p>
+            <a:pPr algn="l"/>
+            <a:r>
+              <a:rPr b="1" sz="1800">
+                <a:solidFill>
+                  <a:srgbClr val="000000"/>
+                </a:solidFill>
+              </a:rPr>
+              <a:t>Vocabulary</a:t>
+            </a:r>
+          </a:p>
+        </p:txBody>
+      </p:sp>
+      <p:sp>
+        <p:nvSpPr>
+          <p:cNvPr id="23" name="TextBox 22"/>
+          <p:cNvSpPr txBox="1"/>
+          <p:nvPr/>
+        </p:nvSpPr>
+        <p:spPr>
+          <a:xfrm>
+            <a:off x="7315200" y="2084832"/>
+            <a:ext cx="3566160" cy="365760"/>
+          </a:xfrm>
+          <a:prstGeom prst="rect">
+            <a:avLst/>
+          </a:prstGeom>
+          <a:noFill/>
+        </p:spPr>
+        <p:txBody>
+          <a:bodyPr wrap="square">
+            <a:spAutoFit/>
+          </a:bodyPr>
+          <a:lstStyle/>
+          <a:p>
+            <a:pPr algn="l"/>
+            <a:r>
+              <a:rPr b="1" sz="1400">
+                <a:solidFill>
+                  <a:srgbClr val="666666"/>
+                </a:solidFill>
+              </a:rPr>
+              <a:t>定义 → 文中找对应词</a:t>
+            </a:r>
+          </a:p>
+        </p:txBody>
+      </p:sp>
+      <p:sp>
+        <p:nvSpPr>
+          <p:cNvPr id="24" name="TextBox 23"/>
+          <p:cNvSpPr txBox="1"/>
+          <p:nvPr/>
+        </p:nvSpPr>
+        <p:spPr>
+          <a:xfrm>
+            <a:off x="7315200" y="2423160"/>
+            <a:ext cx="3566160" cy="365760"/>
+          </a:xfrm>
+          <a:prstGeom prst="rect">
+            <a:avLst/>
+          </a:prstGeom>
+          <a:noFill/>
+        </p:spPr>
+        <p:txBody>
+          <a:bodyPr wrap="square">
+            <a:spAutoFit/>
+          </a:bodyPr>
+          <a:lstStyle/>
+          <a:p>
+            <a:pPr algn="l"/>
+            <a:r>
+              <a:rPr b="1" sz="1200">
+                <a:solidFill>
+                  <a:srgbClr val="666666"/>
+                </a:solidFill>
+              </a:rPr>
+              <a:t>得分点：用自己的话改写</a:t>
+            </a:r>
+          </a:p>
+        </p:txBody>
+      </p:sp>
+      <p:sp>
+        <p:nvSpPr>
+          <p:cNvPr id="25" name="Rounded Rectangle 24"/>
+          <p:cNvSpPr/>
+          <p:nvPr/>
+        </p:nvSpPr>
+        <p:spPr>
+          <a:xfrm>
+            <a:off x="6217920" y="3108960"/>
+            <a:ext cx="4846320" cy="1383533"/>
+          </a:xfrm>
+          <a:prstGeom prst="roundRect">
+            <a:avLst/>
+          </a:prstGeom>
+          <a:solidFill>
+            <a:srgbClr val="F5F0FA"/>
+          </a:solidFill>
+          <a:ln>
+            <a:noFill/>
+          </a:ln>
+        </p:spPr>
+        <p:style>
+          <a:lnRef idx="1">
+            <a:schemeClr val="accent1"/>
+          </a:lnRef>
+          <a:fillRef idx="3">
+            <a:schemeClr val="accent1"/>
+          </a:fillRef>
+          <a:effectRef idx="2">
+            <a:schemeClr val="accent1"/>
+          </a:effectRef>
+          <a:fontRef idx="minor">
+            <a:schemeClr val="lt1"/>
+          </a:fontRef>
+        </p:style>
+        <p:txBody>
+          <a:bodyPr rtlCol="0" anchor="ctr"/>
+          <a:lstStyle/>
+          <a:p>
+            <a:pPr algn="ctr"/>
+          </a:p>
+        </p:txBody>
+      </p:sp>
+      <p:sp>
+        <p:nvSpPr>
+          <p:cNvPr id="26" name="TextBox 25"/>
+          <p:cNvSpPr txBox="1"/>
+          <p:nvPr/>
+        </p:nvSpPr>
+        <p:spPr>
+          <a:xfrm>
+            <a:off x="6400800" y="3291840"/>
+            <a:ext cx="822960" cy="731520"/>
+          </a:xfrm>
+          <a:prstGeom prst="rect">
+            <a:avLst/>
+          </a:prstGeom>
+          <a:noFill/>
+        </p:spPr>
+        <p:txBody>
+          <a:bodyPr wrap="square">
+            <a:spAutoFit/>
+          </a:bodyPr>
+          <a:lstStyle/>
+          <a:p>
+            <a:pPr algn="ctr"/>
+            <a:r>
+              <a:rPr b="1" sz="2400">
+                <a:solidFill>
+                  <a:srgbClr val="2E864B"/>
+                </a:solidFill>
+              </a:rPr>
+              <a:t>Q6</a:t>
+            </a:r>
+          </a:p>
+        </p:txBody>
+      </p:sp>
+      <p:sp>
+        <p:nvSpPr>
+          <p:cNvPr id="27" name="TextBox 26"/>
+          <p:cNvSpPr txBox="1"/>
+          <p:nvPr/>
+        </p:nvSpPr>
+        <p:spPr>
+          <a:xfrm>
+            <a:off x="7315200" y="3291840"/>
+            <a:ext cx="3566160" cy="457200"/>
+          </a:xfrm>
+          <a:prstGeom prst="rect">
+            <a:avLst/>
+          </a:prstGeom>
+          <a:noFill/>
+        </p:spPr>
+        <p:txBody>
+          <a:bodyPr wrap="square">
+            <a:spAutoFit/>
+          </a:bodyPr>
+          <a:lstStyle/>
+          <a:p>
+            <a:pPr algn="l"/>
+            <a:r>
+              <a:rPr b="1" sz="1800">
+                <a:solidFill>
+                  <a:srgbClr val="000000"/>
+                </a:solidFill>
+              </a:rPr>
+              <a:t>Reference</a:t>
+            </a:r>
+          </a:p>
+        </p:txBody>
+      </p:sp>
+      <p:sp>
+        <p:nvSpPr>
+          <p:cNvPr id="28" name="TextBox 27"/>
+          <p:cNvSpPr txBox="1"/>
+          <p:nvPr/>
+        </p:nvSpPr>
+        <p:spPr>
+          <a:xfrm>
+            <a:off x="7315200" y="3730752"/>
+            <a:ext cx="3566160" cy="365760"/>
+          </a:xfrm>
+          <a:prstGeom prst="rect">
+            <a:avLst/>
+          </a:prstGeom>
+          <a:noFill/>
+        </p:spPr>
+        <p:txBody>
+          <a:bodyPr wrap="square">
+            <a:spAutoFit/>
+          </a:bodyPr>
+          <a:lstStyle/>
+          <a:p>
+            <a:pPr algn="l"/>
+            <a:r>
+              <a:rPr b="1" sz="1400">
+                <a:solidFill>
+                  <a:srgbClr val="666666"/>
+                </a:solidFill>
+              </a:rPr>
+              <a:t>"it" / "this" 指什么？</a:t>
+            </a:r>
+          </a:p>
+        </p:txBody>
+      </p:sp>
+      <p:sp>
+        <p:nvSpPr>
+          <p:cNvPr id="29" name="Rectangle 28"/>
+          <p:cNvSpPr/>
+          <p:nvPr/>
+        </p:nvSpPr>
+        <p:spPr>
+          <a:xfrm>
+            <a:off x="5943600" y="1645920"/>
+            <a:ext cx="45720" cy="4114800"/>
+          </a:xfrm>
+          <a:prstGeom prst="rect">
             <a:avLst/>
           </a:prstGeom>
           <a:solidFill>
@@ -4737,14 +5641,14 @@
       </p:sp>
       <p:sp>
         <p:nvSpPr>
-          <p:cNvPr id="5" name="TextBox 4"/>
+          <p:cNvPr id="30" name="TextBox 29"/>
           <p:cNvSpPr txBox="1"/>
           <p:nvPr/>
         </p:nvSpPr>
         <p:spPr>
           <a:xfrm>
-            <a:off x="1089660" y="1645920"/>
-            <a:ext cx="2194560" cy="731520"/>
+            <a:off x="914400" y="5931000"/>
+            <a:ext cx="10058400" cy="365760"/>
           </a:xfrm>
           <a:prstGeom prst="rect">
             <a:avLst/>
@@ -4757,422 +5661,21 @@
           </a:bodyPr>
           <a:lstStyle/>
           <a:p>
-            <a:pPr algn="ctr"/>
-            <a:r>
-              <a:rPr b="1" sz="2400">
-                <a:solidFill>
-                  <a:srgbClr val="FFFFFF"/>
-                </a:solidFill>
-              </a:rPr>
-              <a:t>paper</a:t>
-            </a:r>
-          </a:p>
-        </p:txBody>
-      </p:sp>
-      <p:sp>
-        <p:nvSpPr>
-          <p:cNvPr id="6" name="TextBox 5"/>
-          <p:cNvSpPr txBox="1"/>
-          <p:nvPr/>
-        </p:nvSpPr>
-        <p:spPr>
-          <a:xfrm>
-            <a:off x="1089660" y="2555760"/>
-            <a:ext cx="2194560" cy="548640"/>
-          </a:xfrm>
-          <a:prstGeom prst="rect">
-            <a:avLst/>
-          </a:prstGeom>
-          <a:noFill/>
-        </p:spPr>
-        <p:txBody>
-          <a:bodyPr wrap="square">
-            <a:spAutoFit/>
-          </a:bodyPr>
-          <a:lstStyle/>
-          <a:p>
-            <a:pPr algn="ctr"/>
-            <a:r>
-              <a:rPr b="1" sz="2000">
-                <a:solidFill>
-                  <a:srgbClr val="DDDDFF"/>
-                </a:solidFill>
-              </a:rPr>
-              <a:t>499×</a:t>
-            </a:r>
-          </a:p>
-        </p:txBody>
-      </p:sp>
-      <p:sp>
-        <p:nvSpPr>
-          <p:cNvPr id="7" name="Rounded Rectangle 6"/>
-          <p:cNvSpPr/>
-          <p:nvPr/>
-        </p:nvSpPr>
-        <p:spPr>
-          <a:xfrm>
-            <a:off x="3604260" y="1463040"/>
-            <a:ext cx="2377440" cy="2194560"/>
-          </a:xfrm>
-          <a:prstGeom prst="roundRect">
-            <a:avLst/>
-          </a:prstGeom>
-          <a:solidFill>
-            <a:srgbClr val="502379"/>
-          </a:solidFill>
-          <a:ln>
-            <a:noFill/>
-          </a:ln>
-        </p:spPr>
-        <p:style>
-          <a:lnRef idx="1">
-            <a:schemeClr val="accent1"/>
-          </a:lnRef>
-          <a:fillRef idx="3">
-            <a:schemeClr val="accent1"/>
-          </a:fillRef>
-          <a:effectRef idx="2">
-            <a:schemeClr val="accent1"/>
-          </a:effectRef>
-          <a:fontRef idx="minor">
-            <a:schemeClr val="lt1"/>
-          </a:fontRef>
-        </p:style>
-        <p:txBody>
-          <a:bodyPr rtlCol="0" anchor="ctr"/>
-          <a:lstStyle/>
-          <a:p>
-            <a:pPr algn="ctr"/>
-          </a:p>
-        </p:txBody>
-      </p:sp>
-      <p:sp>
-        <p:nvSpPr>
-          <p:cNvPr id="8" name="TextBox 7"/>
-          <p:cNvSpPr txBox="1"/>
-          <p:nvPr/>
-        </p:nvSpPr>
-        <p:spPr>
-          <a:xfrm>
-            <a:off x="3695700" y="1645920"/>
-            <a:ext cx="2194560" cy="731520"/>
-          </a:xfrm>
-          <a:prstGeom prst="rect">
-            <a:avLst/>
-          </a:prstGeom>
-          <a:noFill/>
-        </p:spPr>
-        <p:txBody>
-          <a:bodyPr wrap="square">
-            <a:spAutoFit/>
-          </a:bodyPr>
-          <a:lstStyle/>
-          <a:p>
-            <a:pPr algn="ctr"/>
-            <a:r>
-              <a:rPr b="1" sz="2400">
-                <a:solidFill>
-                  <a:srgbClr val="FFFFFF"/>
-                </a:solidFill>
-              </a:rPr>
-              <a:t>study</a:t>
-            </a:r>
-          </a:p>
-        </p:txBody>
-      </p:sp>
-      <p:sp>
-        <p:nvSpPr>
-          <p:cNvPr id="9" name="TextBox 8"/>
-          <p:cNvSpPr txBox="1"/>
-          <p:nvPr/>
-        </p:nvSpPr>
-        <p:spPr>
-          <a:xfrm>
-            <a:off x="3695700" y="2555760"/>
-            <a:ext cx="2194560" cy="548640"/>
-          </a:xfrm>
-          <a:prstGeom prst="rect">
-            <a:avLst/>
-          </a:prstGeom>
-          <a:noFill/>
-        </p:spPr>
-        <p:txBody>
-          <a:bodyPr wrap="square">
-            <a:spAutoFit/>
-          </a:bodyPr>
-          <a:lstStyle/>
-          <a:p>
-            <a:pPr algn="ctr"/>
-            <a:r>
-              <a:rPr b="1" sz="2000">
-                <a:solidFill>
-                  <a:srgbClr val="DDDDFF"/>
-                </a:solidFill>
-              </a:rPr>
-              <a:t>170×</a:t>
-            </a:r>
-          </a:p>
-        </p:txBody>
-      </p:sp>
-      <p:sp>
-        <p:nvSpPr>
-          <p:cNvPr id="10" name="Rounded Rectangle 9"/>
-          <p:cNvSpPr/>
-          <p:nvPr/>
-        </p:nvSpPr>
-        <p:spPr>
-          <a:xfrm>
-            <a:off x="6210300" y="1463040"/>
-            <a:ext cx="2377440" cy="2194560"/>
-          </a:xfrm>
-          <a:prstGeom prst="roundRect">
-            <a:avLst/>
-          </a:prstGeom>
-          <a:solidFill>
-            <a:srgbClr val="7C3A9E"/>
-          </a:solidFill>
-          <a:ln>
-            <a:noFill/>
-          </a:ln>
-        </p:spPr>
-        <p:style>
-          <a:lnRef idx="1">
-            <a:schemeClr val="accent1"/>
-          </a:lnRef>
-          <a:fillRef idx="3">
-            <a:schemeClr val="accent1"/>
-          </a:fillRef>
-          <a:effectRef idx="2">
-            <a:schemeClr val="accent1"/>
-          </a:effectRef>
-          <a:fontRef idx="minor">
-            <a:schemeClr val="lt1"/>
-          </a:fontRef>
-        </p:style>
-        <p:txBody>
-          <a:bodyPr rtlCol="0" anchor="ctr"/>
-          <a:lstStyle/>
-          <a:p>
-            <a:pPr algn="ctr"/>
-          </a:p>
-        </p:txBody>
-      </p:sp>
-      <p:sp>
-        <p:nvSpPr>
-          <p:cNvPr id="11" name="TextBox 10"/>
-          <p:cNvSpPr txBox="1"/>
-          <p:nvPr/>
-        </p:nvSpPr>
-        <p:spPr>
-          <a:xfrm>
-            <a:off x="6301740" y="1645920"/>
-            <a:ext cx="2194560" cy="731520"/>
-          </a:xfrm>
-          <a:prstGeom prst="rect">
-            <a:avLst/>
-          </a:prstGeom>
-          <a:noFill/>
-        </p:spPr>
-        <p:txBody>
-          <a:bodyPr wrap="square">
-            <a:spAutoFit/>
-          </a:bodyPr>
-          <a:lstStyle/>
-          <a:p>
-            <a:pPr algn="ctr"/>
-            <a:r>
-              <a:rPr b="1" sz="2400">
-                <a:solidFill>
-                  <a:srgbClr val="FFFFFF"/>
-                </a:solidFill>
-              </a:rPr>
-              <a:t>research</a:t>
-            </a:r>
-          </a:p>
-        </p:txBody>
-      </p:sp>
-      <p:sp>
-        <p:nvSpPr>
-          <p:cNvPr id="12" name="TextBox 11"/>
-          <p:cNvSpPr txBox="1"/>
-          <p:nvPr/>
-        </p:nvSpPr>
-        <p:spPr>
-          <a:xfrm>
-            <a:off x="6301740" y="2555760"/>
-            <a:ext cx="2194560" cy="548640"/>
-          </a:xfrm>
-          <a:prstGeom prst="rect">
-            <a:avLst/>
-          </a:prstGeom>
-          <a:noFill/>
-        </p:spPr>
-        <p:txBody>
-          <a:bodyPr wrap="square">
-            <a:spAutoFit/>
-          </a:bodyPr>
-          <a:lstStyle/>
-          <a:p>
-            <a:pPr algn="ctr"/>
-            <a:r>
-              <a:rPr b="1" sz="2000">
-                <a:solidFill>
-                  <a:srgbClr val="DDDDFF"/>
-                </a:solidFill>
-              </a:rPr>
-              <a:t>154×</a:t>
-            </a:r>
-          </a:p>
-        </p:txBody>
-      </p:sp>
-      <p:sp>
-        <p:nvSpPr>
-          <p:cNvPr id="13" name="Rounded Rectangle 12"/>
-          <p:cNvSpPr/>
-          <p:nvPr/>
-        </p:nvSpPr>
-        <p:spPr>
-          <a:xfrm>
-            <a:off x="8816340" y="1463040"/>
-            <a:ext cx="2377440" cy="2194560"/>
-          </a:xfrm>
-          <a:prstGeom prst="roundRect">
-            <a:avLst/>
-          </a:prstGeom>
-          <a:solidFill>
-            <a:srgbClr val="502379"/>
-          </a:solidFill>
-          <a:ln>
-            <a:noFill/>
-          </a:ln>
-        </p:spPr>
-        <p:style>
-          <a:lnRef idx="1">
-            <a:schemeClr val="accent1"/>
-          </a:lnRef>
-          <a:fillRef idx="3">
-            <a:schemeClr val="accent1"/>
-          </a:fillRef>
-          <a:effectRef idx="2">
-            <a:schemeClr val="accent1"/>
-          </a:effectRef>
-          <a:fontRef idx="minor">
-            <a:schemeClr val="lt1"/>
-          </a:fontRef>
-        </p:style>
-        <p:txBody>
-          <a:bodyPr rtlCol="0" anchor="ctr"/>
-          <a:lstStyle/>
-          <a:p>
-            <a:pPr algn="ctr"/>
-          </a:p>
-        </p:txBody>
-      </p:sp>
-      <p:sp>
-        <p:nvSpPr>
-          <p:cNvPr id="14" name="TextBox 13"/>
-          <p:cNvSpPr txBox="1"/>
-          <p:nvPr/>
-        </p:nvSpPr>
-        <p:spPr>
-          <a:xfrm>
-            <a:off x="8907780" y="1645920"/>
-            <a:ext cx="2194560" cy="731520"/>
-          </a:xfrm>
-          <a:prstGeom prst="rect">
-            <a:avLst/>
-          </a:prstGeom>
-          <a:noFill/>
-        </p:spPr>
-        <p:txBody>
-          <a:bodyPr wrap="square">
-            <a:spAutoFit/>
-          </a:bodyPr>
-          <a:lstStyle/>
-          <a:p>
-            <a:pPr algn="ctr"/>
-            <a:r>
-              <a:rPr b="1" sz="2400">
-                <a:solidFill>
-                  <a:srgbClr val="FFFFFF"/>
-                </a:solidFill>
-              </a:rPr>
-              <a:t>work</a:t>
-            </a:r>
-          </a:p>
-        </p:txBody>
-      </p:sp>
-      <p:sp>
-        <p:nvSpPr>
-          <p:cNvPr id="15" name="TextBox 14"/>
-          <p:cNvSpPr txBox="1"/>
-          <p:nvPr/>
-        </p:nvSpPr>
-        <p:spPr>
-          <a:xfrm>
-            <a:off x="8907780" y="2555760"/>
-            <a:ext cx="2194560" cy="548640"/>
-          </a:xfrm>
-          <a:prstGeom prst="rect">
-            <a:avLst/>
-          </a:prstGeom>
-          <a:noFill/>
-        </p:spPr>
-        <p:txBody>
-          <a:bodyPr wrap="square">
-            <a:spAutoFit/>
-          </a:bodyPr>
-          <a:lstStyle/>
-          <a:p>
-            <a:pPr algn="ctr"/>
-            <a:r>
-              <a:rPr b="1" sz="2000">
-                <a:solidFill>
-                  <a:srgbClr val="DDDDFF"/>
-                </a:solidFill>
-              </a:rPr>
-              <a:t>111×</a:t>
-            </a:r>
-          </a:p>
-        </p:txBody>
-      </p:sp>
-      <p:sp>
-        <p:nvSpPr>
-          <p:cNvPr id="16" name="TextBox 15"/>
-          <p:cNvSpPr txBox="1"/>
-          <p:nvPr/>
-        </p:nvSpPr>
-        <p:spPr>
-          <a:xfrm>
-            <a:off x="914400" y="4206240"/>
-            <a:ext cx="10058400" cy="457200"/>
-          </a:xfrm>
-          <a:prstGeom prst="rect">
-            <a:avLst/>
-          </a:prstGeom>
-          <a:noFill/>
-        </p:spPr>
-        <p:txBody>
-          <a:bodyPr wrap="square">
-            <a:spAutoFit/>
-          </a:bodyPr>
-          <a:lstStyle/>
-          <a:p>
             <a:pPr algn="l"/>
             <a:r>
               <a:rPr b="1" sz="1400">
                 <a:solidFill>
-                  <a:srgbClr val="666666"/>
-                </a:solidFill>
-              </a:rPr>
-              <a:t>investigate · examine · analyse · indicate · suggest</a:t>
-            </a:r>
-          </a:p>
-        </p:txBody>
-      </p:sp>
-      <p:sp>
-        <p:nvSpPr>
-          <p:cNvPr id="17" name="TextBox 16"/>
+                  <a:srgbClr val="FF0000"/>
+                </a:solidFill>
+              </a:rPr>
+              <a:t>⚠ All answers must be PARAPHRASED — no copying</a:t>
+            </a:r>
+          </a:p>
+        </p:txBody>
+      </p:sp>
+      <p:sp>
+        <p:nvSpPr>
+          <p:cNvPr id="31" name="TextBox 30"/>
           <p:cNvSpPr txBox="1"/>
           <p:nvPr/>
         </p:nvSpPr>

</xml_diff>